<commit_message>
Tier-0 audit: the lifecycle and edge-case phases, and fixture photographs the classifier accepts
stock-tier0-lifecycle follows one list through publication, both UIs in a
real browser, a Command Centre activation through select_for_client, the
portal acknowledgement, a v2 re-upload, the builder's own edits, a second
organisation with the same estate and lot, a deleted list and a withdrawn
activation. stock-tier0-edges covers refused, malformed, partial,
duplicate, unusual, Unicode and oversized input and the upload-flow clicks.

The fixtures' facade photographs are now only seeds the product's own
assessMarketplaceEligibility accepts, measured on the exact bytes each
format embeds; the first run showed three of the old seeds refused as
marketing tiles, which made the run a statement about the fixture.

Co-Authored-By: Claude Opus 5.5 <noreply@anthropic.com>
Claude-Session: https://claude.ai/code/session_018BjHXw6oqXMjrQzqoMowt6
</commit_message>
<xml_diff>
--- a/scripts/ops/fixtures/tier0/pptx.pptx
+++ b/scripts/ops/fixtures/tier0/pptx.pptx
@@ -3632,7 +3632,7 @@
       </p:graphicFrame>
       <p:pic>
         <p:nvPicPr>
-          <p:cNvPr id="4" name="Picture 3" descr="facade-451.jpg"/>
+          <p:cNvPr id="4" name="Picture 3" descr="facade-436.jpg"/>
           <p:cNvPicPr>
             <a:picLocks noChangeAspect="1"/>
           </p:cNvPicPr>
@@ -4215,7 +4215,7 @@
       </p:graphicFrame>
       <p:pic>
         <p:nvPicPr>
-          <p:cNvPr id="4" name="Picture 3" descr="facade-452.jpg"/>
+          <p:cNvPr id="4" name="Picture 3" descr="facade-437.jpg"/>
           <p:cNvPicPr>
             <a:picLocks noChangeAspect="1"/>
           </p:cNvPicPr>

</xml_diff>